<commit_message>
Expand references beyond sixty
</commit_message>
<xml_diff>
--- a/docs/code_explanation_presentation.pptx
+++ b/docs/code_explanation_presentation.pptx
@@ -4795,7 +4795,7 @@
                 </a:solidFill>
                 <a:latin typeface="Arial"/>
               </a:rPr>
-              <a:t>Expected validation result: 42 citation keys, 42 bibliography entries, reference validation passed.</a:t>
+              <a:t>Expected validation result: 67 citation keys, 67 bibliography entries, reference validation passed.</a:t>
             </a:r>
           </a:p>
         </p:txBody>
@@ -6325,7 +6325,7 @@
                 </a:solidFill>
                 <a:latin typeface="Arial"/>
               </a:rPr>
-              <a:t>Current check: 42 citation keys and 42 bibliography entries.</a:t>
+              <a:t>Current check: 67 citation keys and 67 bibliography entries.</a:t>
             </a:r>
           </a:p>
         </p:txBody>

</xml_diff>

<commit_message>
Align paper with course final report guideline
</commit_message>
<xml_diff>
--- a/docs/code_explanation_presentation.pptx
+++ b/docs/code_explanation_presentation.pptx
@@ -4795,7 +4795,7 @@
                 </a:solidFill>
                 <a:latin typeface="Arial"/>
               </a:rPr>
-              <a:t>Expected validation result: 67 citation keys, 67 bibliography entries, reference validation passed.</a:t>
+              <a:t>Expected validation result: 68 citation keys, 68 bibliography entries, reference validation passed.</a:t>
             </a:r>
           </a:p>
         </p:txBody>
@@ -6325,7 +6325,7 @@
                 </a:solidFill>
                 <a:latin typeface="Arial"/>
               </a:rPr>
-              <a:t>Current check: 67 citation keys and 67 bibliography entries.</a:t>
+              <a:t>Current check: 68 citation keys and 68 bibliography entries.</a:t>
             </a:r>
           </a:p>
         </p:txBody>
@@ -7380,7 +7380,7 @@
                 </a:solidFill>
                 <a:latin typeface="Arial"/>
               </a:rPr>
-              <a:t>Sets Letter page size, narrow margins, 10 pt body text, 12 pt headings, and a footer rule.</a:t>
+              <a:t>Sets A4 page size, 2.5 cm margins, 10 pt body text, bold headings, 1.5 line spacing, and a footer rule with centered page number.</a:t>
             </a:r>
           </a:p>
         </p:txBody>
@@ -7455,7 +7455,7 @@
                 </a:solidFill>
                 <a:latin typeface="Consolas"/>
               </a:rPr>
-              <a:t>section.page_width = Cm(21.59)</a:t>
+              <a:t>section.page_width = Cm(21)</a:t>
             </a:r>
             <a:br/>
             <a:r>
@@ -7465,7 +7465,17 @@
                 </a:solidFill>
                 <a:latin typeface="Consolas"/>
               </a:rPr>
-              <a:t>section.page_height = Cm(27.94)</a:t>
+              <a:t>section.page_height = Cm(29.7)</a:t>
+            </a:r>
+            <a:br/>
+            <a:r>
+              <a:rPr sz="1000">
+                <a:solidFill>
+                  <a:srgbClr val="282828"/>
+                </a:solidFill>
+                <a:latin typeface="Consolas"/>
+              </a:rPr>
+              <a:t>section.left_margin = Cm(2.5)</a:t>
             </a:r>
             <a:br/>
             <a:r>
@@ -7728,7 +7738,7 @@
                 </a:solidFill>
                 <a:latin typeface="Arial"/>
               </a:rPr>
-              <a:t>Verified page size: 612 x 792 pt, matching the sample.</a:t>
+              <a:t>Checks the final PDF against the sample while following the course A4 and 2.5 cm margin requirement.</a:t>
             </a:r>
           </a:p>
           <a:p>
@@ -7744,7 +7754,7 @@
                 </a:solidFill>
                 <a:latin typeface="Arial"/>
               </a:rPr>
-              <a:t>Verified side margins are close to the sample: about 133 pt.</a:t>
+              <a:t>Confirms footer rule, page numbers, fonts, captions, and source notes in the final submission.</a:t>
             </a:r>
           </a:p>
         </p:txBody>

</xml_diff>